<commit_message>
Add app slide to trailer deck
Insert a companion-app slide (sleep score, oxygen + events, position)
between How-It-Works and the validation slide; deck is now 4 slides.

Co-Authored-By: Claude Opus 4.8 <noreply@anthropic.com>
Claude-Session: https://claude.ai/code/session_01CxrUMy4UZKTNYh6kiz9919
</commit_message>
<xml_diff>
--- a/science-fair/night-signal/Night_Signal_Trailer.pptx
+++ b/science-fair/night-signal/Night_Signal_Trailer.pptx
@@ -8,9 +8,10 @@
     <p:sldId id="256" r:id="rId2"/>
     <p:sldId id="257" r:id="rId3"/>
     <p:sldId id="258" r:id="rId4"/>
+    <p:sldId id="259" r:id="rId5"/>
   </p:sldIdLst>
   <p:notesMasterIdLst>
-    <p:notesMasterId r:id="rId5"/>
+    <p:notesMasterId r:id="rId6"/>
   </p:notesMasterIdLst>
   <p:sldSz cx="12191695" cy="6858000"/>
   <p:notesSz cx="6858000" cy="12191695"/>
@@ -680,7 +681,7 @@
           <a:p>
             <a:r>
               <a:rPr lang="en-US" dirty="0"/>
-              <a:t>We validated the device against a reference oximeter (within about half a percent, correlation 0.89), built a machine-learning detector that catches 82% of events, and tested all four analyses in code. The Bland-Altman plot is the standard medical way to show two devices agree.</a:t>
+              <a:t>The companion app turns the raw data into a friendly sleep report: a sleep score, the night's oxygen graph with apnea events marked, and cards for heart rate, breathing and sleep position. Record overnight, open the app in the morning.</a:t>
             </a:r>
             <a:endParaRPr lang="en-US" dirty="0"/>
           </a:p>
@@ -704,6 +705,94 @@
             <a:fld id="{F7021451-1387-4CA6-816F-3879F97B5CBC}" type="slidenum">
               <a:rPr lang="en-US"/>
               <a:t>3</a:t>
+            </a:fld>
+            <a:endParaRPr lang="en-US"/>
+          </a:p>
+        </p:txBody>
+      </p:sp>
+    </p:spTree>
+    <p:extLst>
+      <p:ext uri="{BB962C8B-B14F-4D97-AF65-F5344CB8AC3E}">
+        <p14:creationId xmlns:p14="http://schemas.microsoft.com/office/powerpoint/2010/main" val="1024086991"/>
+      </p:ext>
+    </p:extLst>
+  </p:cSld>
+  <p:clrMapOvr>
+    <a:masterClrMapping/>
+  </p:clrMapOvr>
+</p:notes>
+</file>
+
+<file path=ppt/notesSlides/notesSlide4.xml><?xml version="1.0" encoding="utf-8"?>
+<p:notes xmlns:a="http://schemas.openxmlformats.org/drawingml/2006/main" xmlns:r="http://schemas.openxmlformats.org/officeDocument/2006/relationships" xmlns:p="http://schemas.openxmlformats.org/presentationml/2006/main">
+  <p:cSld>
+    <p:spTree>
+      <p:nvGrpSpPr>
+        <p:cNvPr id="1" name=""/>
+        <p:cNvGrpSpPr/>
+        <p:nvPr/>
+      </p:nvGrpSpPr>
+      <p:grpSpPr>
+        <a:xfrm>
+          <a:off x="0" y="0"/>
+          <a:ext cx="0" cy="0"/>
+          <a:chOff x="0" y="0"/>
+          <a:chExt cx="0" cy="0"/>
+        </a:xfrm>
+      </p:grpSpPr>
+      <p:sp>
+        <p:nvSpPr>
+          <p:cNvPr id="2" name="Slide Image Placeholder 1"/>
+          <p:cNvSpPr>
+            <a:spLocks noGrp="1" noRot="1" noChangeAspect="1"/>
+          </p:cNvSpPr>
+          <p:nvPr>
+            <p:ph type="sldImg"/>
+          </p:nvPr>
+        </p:nvSpPr>
+        <p:spPr/>
+      </p:sp>
+      <p:sp>
+        <p:nvSpPr>
+          <p:cNvPr id="3" name="Notes Placeholder 2"/>
+          <p:cNvSpPr>
+            <a:spLocks noGrp="1"/>
+          </p:cNvSpPr>
+          <p:nvPr>
+            <p:ph type="body" idx="1"/>
+          </p:nvPr>
+        </p:nvSpPr>
+        <p:spPr/>
+        <p:txBody>
+          <a:bodyPr/>
+          <a:lstStyle/>
+          <a:p>
+            <a:r>
+              <a:rPr lang="en-US" dirty="0"/>
+              <a:t>We validated the device against a reference oximeter (within about half a percent, correlation 0.89), built a machine-learning detector that catches 82% of events, and tested all four analyses in code. The Bland-Altman plot is the standard medical way to show two devices agree.</a:t>
+            </a:r>
+            <a:endParaRPr lang="en-US" dirty="0"/>
+          </a:p>
+        </p:txBody>
+      </p:sp>
+      <p:sp>
+        <p:nvSpPr>
+          <p:cNvPr id="4" name="Slide Number Placeholder 3"/>
+          <p:cNvSpPr>
+            <a:spLocks noGrp="1"/>
+          </p:cNvSpPr>
+          <p:nvPr>
+            <p:ph type="sldNum" sz="quarter" idx="10"/>
+          </p:nvPr>
+        </p:nvSpPr>
+        <p:spPr/>
+        <p:txBody>
+          <a:bodyPr/>
+          <a:lstStyle/>
+          <a:p>
+            <a:fld id="{F7021451-1387-4CA6-816F-3879F97B5CBC}" type="slidenum">
+              <a:rPr lang="en-US"/>
+              <a:t>4</a:t>
             </a:fld>
             <a:endParaRPr lang="en-US"/>
           </a:p>
@@ -2218,6 +2307,503 @@
     <p:bg>
       <p:bgPr>
         <a:solidFill>
+          <a:srgbClr val="FFFFFF"/>
+        </a:solidFill>
+      </p:bgPr>
+    </p:bg>
+    <p:spTree>
+      <p:nvGrpSpPr>
+        <p:cNvPr id="1" name=""/>
+        <p:cNvGrpSpPr/>
+        <p:nvPr/>
+      </p:nvGrpSpPr>
+      <p:grpSpPr>
+        <a:xfrm>
+          <a:off x="0" y="0"/>
+          <a:ext cx="0" cy="0"/>
+          <a:chOff x="0" y="0"/>
+          <a:chExt cx="0" cy="0"/>
+        </a:xfrm>
+      </p:grpSpPr>
+      <p:sp>
+        <p:nvSpPr>
+          <p:cNvPr id="2" name="Text 0"/>
+          <p:cNvSpPr txBox="1"/>
+          <p:nvPr/>
+        </p:nvSpPr>
+        <p:spPr>
+          <a:xfrm>
+            <a:off x="640080" y="502920"/>
+            <a:ext cx="7315200" cy="274320"/>
+          </a:xfrm>
+          <a:prstGeom prst="rect">
+            <a:avLst/>
+          </a:prstGeom>
+          <a:noFill/>
+          <a:ln/>
+        </p:spPr>
+        <p:txBody>
+          <a:bodyPr wrap="square" lIns="0" tIns="0" rIns="0" bIns="0" rtlCol="0" anchor="ctr"/>
+          <a:lstStyle/>
+          <a:p>
+            <a:pPr indent="0" marL="0">
+              <a:buNone/>
+            </a:pPr>
+            <a:r>
+              <a:rPr lang="en-US" sz="1200" b="1" spc="300" kern="0" dirty="0">
+                <a:solidFill>
+                  <a:srgbClr val="1F8A9C"/>
+                </a:solidFill>
+                <a:latin typeface="Calibri" pitchFamily="34" charset="0"/>
+                <a:ea typeface="Calibri" pitchFamily="34" charset="-122"/>
+                <a:cs typeface="Calibri" pitchFamily="34" charset="-120"/>
+              </a:rPr>
+              <a:t>THE COMPANION APP</a:t>
+            </a:r>
+            <a:endParaRPr lang="en-US" sz="1200" dirty="0"/>
+          </a:p>
+        </p:txBody>
+      </p:sp>
+      <p:sp>
+        <p:nvSpPr>
+          <p:cNvPr id="3" name="Text 1"/>
+          <p:cNvSpPr txBox="1"/>
+          <p:nvPr/>
+        </p:nvSpPr>
+        <p:spPr>
+          <a:xfrm>
+            <a:off x="640080" y="868680"/>
+            <a:ext cx="7680960" cy="914400"/>
+          </a:xfrm>
+          <a:prstGeom prst="rect">
+            <a:avLst/>
+          </a:prstGeom>
+          <a:noFill/>
+          <a:ln/>
+        </p:spPr>
+        <p:txBody>
+          <a:bodyPr wrap="square" lIns="0" tIns="0" rIns="0" bIns="0" rtlCol="0" anchor="ctr"/>
+          <a:lstStyle/>
+          <a:p>
+            <a:pPr indent="0" marL="0">
+              <a:lnSpc>
+                <a:spcPts val="3600"/>
+              </a:lnSpc>
+              <a:buNone/>
+            </a:pPr>
+            <a:r>
+              <a:rPr lang="en-US" sz="3400" b="1" dirty="0">
+                <a:solidFill>
+                  <a:srgbClr val="141A26"/>
+                </a:solidFill>
+                <a:latin typeface="Calibri" pitchFamily="34" charset="0"/>
+                <a:ea typeface="Calibri" pitchFamily="34" charset="-122"/>
+                <a:cs typeface="Calibri" pitchFamily="34" charset="-120"/>
+              </a:rPr>
+              <a:t>Your whole night, in your pocket.</a:t>
+            </a:r>
+            <a:endParaRPr lang="en-US" sz="3400" dirty="0"/>
+          </a:p>
+        </p:txBody>
+      </p:sp>
+      <p:sp>
+        <p:nvSpPr>
+          <p:cNvPr id="4" name="Shape 2"/>
+          <p:cNvSpPr/>
+          <p:nvPr/>
+        </p:nvSpPr>
+        <p:spPr>
+          <a:xfrm>
+            <a:off x="685800" y="2331720"/>
+            <a:ext cx="292608" cy="292608"/>
+          </a:xfrm>
+          <a:prstGeom prst="ellipse">
+            <a:avLst/>
+          </a:prstGeom>
+          <a:solidFill>
+            <a:srgbClr val="1F8A9C"/>
+          </a:solidFill>
+          <a:ln/>
+        </p:spPr>
+      </p:sp>
+      <p:sp>
+        <p:nvSpPr>
+          <p:cNvPr id="5" name="Text 3"/>
+          <p:cNvSpPr txBox="1"/>
+          <p:nvPr/>
+        </p:nvSpPr>
+        <p:spPr>
+          <a:xfrm>
+            <a:off x="1143000" y="2240280"/>
+            <a:ext cx="6766560" cy="411480"/>
+          </a:xfrm>
+          <a:prstGeom prst="rect">
+            <a:avLst/>
+          </a:prstGeom>
+          <a:noFill/>
+          <a:ln/>
+        </p:spPr>
+        <p:txBody>
+          <a:bodyPr wrap="square" lIns="0" tIns="0" rIns="0" bIns="0" rtlCol="0" anchor="ctr"/>
+          <a:lstStyle/>
+          <a:p>
+            <a:pPr indent="0" marL="0">
+              <a:buNone/>
+            </a:pPr>
+            <a:r>
+              <a:rPr lang="en-US" sz="1900" b="1" dirty="0">
+                <a:solidFill>
+                  <a:srgbClr val="141A26"/>
+                </a:solidFill>
+                <a:latin typeface="Calibri" pitchFamily="34" charset="0"/>
+                <a:ea typeface="Calibri" pitchFamily="34" charset="-122"/>
+                <a:cs typeface="Calibri" pitchFamily="34" charset="-120"/>
+              </a:rPr>
+              <a:t>Sleep score at a glance</a:t>
+            </a:r>
+            <a:endParaRPr lang="en-US" sz="1900" dirty="0"/>
+          </a:p>
+        </p:txBody>
+      </p:sp>
+      <p:sp>
+        <p:nvSpPr>
+          <p:cNvPr id="6" name="Text 4"/>
+          <p:cNvSpPr txBox="1"/>
+          <p:nvPr/>
+        </p:nvSpPr>
+        <p:spPr>
+          <a:xfrm>
+            <a:off x="1143000" y="2670048"/>
+            <a:ext cx="6766560" cy="457200"/>
+          </a:xfrm>
+          <a:prstGeom prst="rect">
+            <a:avLst/>
+          </a:prstGeom>
+          <a:noFill/>
+          <a:ln/>
+        </p:spPr>
+        <p:txBody>
+          <a:bodyPr wrap="square" lIns="0" tIns="0" rIns="0" bIns="0" rtlCol="0" anchor="ctr"/>
+          <a:lstStyle/>
+          <a:p>
+            <a:pPr indent="0" marL="0">
+              <a:buNone/>
+            </a:pPr>
+            <a:r>
+              <a:rPr lang="en-US" sz="1400" dirty="0">
+                <a:solidFill>
+                  <a:srgbClr val="44515F"/>
+                </a:solidFill>
+                <a:latin typeface="Calibri" pitchFamily="34" charset="0"/>
+                <a:ea typeface="Calibri" pitchFamily="34" charset="-122"/>
+                <a:cs typeface="Calibri" pitchFamily="34" charset="-120"/>
+              </a:rPr>
+              <a:t>One number sums up how the night went.</a:t>
+            </a:r>
+            <a:endParaRPr lang="en-US" sz="1400" dirty="0"/>
+          </a:p>
+        </p:txBody>
+      </p:sp>
+      <p:sp>
+        <p:nvSpPr>
+          <p:cNvPr id="7" name="Shape 5"/>
+          <p:cNvSpPr/>
+          <p:nvPr/>
+        </p:nvSpPr>
+        <p:spPr>
+          <a:xfrm>
+            <a:off x="685800" y="3474720"/>
+            <a:ext cx="292608" cy="292608"/>
+          </a:xfrm>
+          <a:prstGeom prst="ellipse">
+            <a:avLst/>
+          </a:prstGeom>
+          <a:solidFill>
+            <a:srgbClr val="1F8A9C"/>
+          </a:solidFill>
+          <a:ln/>
+        </p:spPr>
+      </p:sp>
+      <p:sp>
+        <p:nvSpPr>
+          <p:cNvPr id="8" name="Text 6"/>
+          <p:cNvSpPr txBox="1"/>
+          <p:nvPr/>
+        </p:nvSpPr>
+        <p:spPr>
+          <a:xfrm>
+            <a:off x="1143000" y="3383280"/>
+            <a:ext cx="6766560" cy="411480"/>
+          </a:xfrm>
+          <a:prstGeom prst="rect">
+            <a:avLst/>
+          </a:prstGeom>
+          <a:noFill/>
+          <a:ln/>
+        </p:spPr>
+        <p:txBody>
+          <a:bodyPr wrap="square" lIns="0" tIns="0" rIns="0" bIns="0" rtlCol="0" anchor="ctr"/>
+          <a:lstStyle/>
+          <a:p>
+            <a:pPr indent="0" marL="0">
+              <a:buNone/>
+            </a:pPr>
+            <a:r>
+              <a:rPr lang="en-US" sz="1900" b="1" dirty="0">
+                <a:solidFill>
+                  <a:srgbClr val="141A26"/>
+                </a:solidFill>
+                <a:latin typeface="Calibri" pitchFamily="34" charset="0"/>
+                <a:ea typeface="Calibri" pitchFamily="34" charset="-122"/>
+                <a:cs typeface="Calibri" pitchFamily="34" charset="-120"/>
+              </a:rPr>
+              <a:t>Oxygen + apnea events</a:t>
+            </a:r>
+            <a:endParaRPr lang="en-US" sz="1900" dirty="0"/>
+          </a:p>
+        </p:txBody>
+      </p:sp>
+      <p:sp>
+        <p:nvSpPr>
+          <p:cNvPr id="9" name="Text 7"/>
+          <p:cNvSpPr txBox="1"/>
+          <p:nvPr/>
+        </p:nvSpPr>
+        <p:spPr>
+          <a:xfrm>
+            <a:off x="1143000" y="3813048"/>
+            <a:ext cx="6766560" cy="457200"/>
+          </a:xfrm>
+          <a:prstGeom prst="rect">
+            <a:avLst/>
+          </a:prstGeom>
+          <a:noFill/>
+          <a:ln/>
+        </p:spPr>
+        <p:txBody>
+          <a:bodyPr wrap="square" lIns="0" tIns="0" rIns="0" bIns="0" rtlCol="0" anchor="ctr"/>
+          <a:lstStyle/>
+          <a:p>
+            <a:pPr indent="0" marL="0">
+              <a:buNone/>
+            </a:pPr>
+            <a:r>
+              <a:rPr lang="en-US" sz="1400" dirty="0">
+                <a:solidFill>
+                  <a:srgbClr val="44515F"/>
+                </a:solidFill>
+                <a:latin typeface="Calibri" pitchFamily="34" charset="0"/>
+                <a:ea typeface="Calibri" pitchFamily="34" charset="-122"/>
+                <a:cs typeface="Calibri" pitchFamily="34" charset="-120"/>
+              </a:rPr>
+              <a:t>The full night's SpO₂, with every event in red.</a:t>
+            </a:r>
+            <a:endParaRPr lang="en-US" sz="1400" dirty="0"/>
+          </a:p>
+        </p:txBody>
+      </p:sp>
+      <p:sp>
+        <p:nvSpPr>
+          <p:cNvPr id="10" name="Shape 8"/>
+          <p:cNvSpPr/>
+          <p:nvPr/>
+        </p:nvSpPr>
+        <p:spPr>
+          <a:xfrm>
+            <a:off x="685800" y="4617720"/>
+            <a:ext cx="292608" cy="292608"/>
+          </a:xfrm>
+          <a:prstGeom prst="ellipse">
+            <a:avLst/>
+          </a:prstGeom>
+          <a:solidFill>
+            <a:srgbClr val="1F8A9C"/>
+          </a:solidFill>
+          <a:ln/>
+        </p:spPr>
+      </p:sp>
+      <p:sp>
+        <p:nvSpPr>
+          <p:cNvPr id="11" name="Text 9"/>
+          <p:cNvSpPr txBox="1"/>
+          <p:nvPr/>
+        </p:nvSpPr>
+        <p:spPr>
+          <a:xfrm>
+            <a:off x="1143000" y="4526280"/>
+            <a:ext cx="6766560" cy="411480"/>
+          </a:xfrm>
+          <a:prstGeom prst="rect">
+            <a:avLst/>
+          </a:prstGeom>
+          <a:noFill/>
+          <a:ln/>
+        </p:spPr>
+        <p:txBody>
+          <a:bodyPr wrap="square" lIns="0" tIns="0" rIns="0" bIns="0" rtlCol="0" anchor="ctr"/>
+          <a:lstStyle/>
+          <a:p>
+            <a:pPr indent="0" marL="0">
+              <a:buNone/>
+            </a:pPr>
+            <a:r>
+              <a:rPr lang="en-US" sz="1900" b="1" dirty="0">
+                <a:solidFill>
+                  <a:srgbClr val="141A26"/>
+                </a:solidFill>
+                <a:latin typeface="Calibri" pitchFamily="34" charset="0"/>
+                <a:ea typeface="Calibri" pitchFamily="34" charset="-122"/>
+                <a:cs typeface="Calibri" pitchFamily="34" charset="-120"/>
+              </a:rPr>
+              <a:t>Heart rate, breathing, position</a:t>
+            </a:r>
+            <a:endParaRPr lang="en-US" sz="1900" dirty="0"/>
+          </a:p>
+        </p:txBody>
+      </p:sp>
+      <p:sp>
+        <p:nvSpPr>
+          <p:cNvPr id="12" name="Text 10"/>
+          <p:cNvSpPr txBox="1"/>
+          <p:nvPr/>
+        </p:nvSpPr>
+        <p:spPr>
+          <a:xfrm>
+            <a:off x="1143000" y="4956048"/>
+            <a:ext cx="6766560" cy="457200"/>
+          </a:xfrm>
+          <a:prstGeom prst="rect">
+            <a:avLst/>
+          </a:prstGeom>
+          <a:noFill/>
+          <a:ln/>
+        </p:spPr>
+        <p:txBody>
+          <a:bodyPr wrap="square" lIns="0" tIns="0" rIns="0" bIns="0" rtlCol="0" anchor="ctr"/>
+          <a:lstStyle/>
+          <a:p>
+            <a:pPr indent="0" marL="0">
+              <a:buNone/>
+            </a:pPr>
+            <a:r>
+              <a:rPr lang="en-US" sz="1400" dirty="0">
+                <a:solidFill>
+                  <a:srgbClr val="44515F"/>
+                </a:solidFill>
+                <a:latin typeface="Calibri" pitchFamily="34" charset="0"/>
+                <a:ea typeface="Calibri" pitchFamily="34" charset="-122"/>
+                <a:cs typeface="Calibri" pitchFamily="34" charset="-120"/>
+              </a:rPr>
+              <a:t>All the signals the wearable captured, in plain cards.</a:t>
+            </a:r>
+            <a:endParaRPr lang="en-US" sz="1400" dirty="0"/>
+          </a:p>
+        </p:txBody>
+      </p:sp>
+      <p:sp>
+        <p:nvSpPr>
+          <p:cNvPr id="13" name="Text 11"/>
+          <p:cNvSpPr txBox="1"/>
+          <p:nvPr/>
+        </p:nvSpPr>
+        <p:spPr>
+          <a:xfrm>
+            <a:off x="685800" y="5806440"/>
+            <a:ext cx="7498080" cy="457200"/>
+          </a:xfrm>
+          <a:prstGeom prst="rect">
+            <a:avLst/>
+          </a:prstGeom>
+          <a:noFill/>
+          <a:ln/>
+        </p:spPr>
+        <p:txBody>
+          <a:bodyPr wrap="square" lIns="0" tIns="0" rIns="0" bIns="0" rtlCol="0" anchor="ctr"/>
+          <a:lstStyle/>
+          <a:p>
+            <a:pPr indent="0" marL="0">
+              <a:buNone/>
+            </a:pPr>
+            <a:r>
+              <a:rPr lang="en-US" sz="1450" i="1" dirty="0">
+                <a:solidFill>
+                  <a:srgbClr val="1F8A9C"/>
+                </a:solidFill>
+                <a:latin typeface="Calibri" pitchFamily="34" charset="0"/>
+                <a:ea typeface="Calibri" pitchFamily="34" charset="-122"/>
+                <a:cs typeface="Calibri" pitchFamily="34" charset="-120"/>
+              </a:rPr>
+              <a:t>Record overnight → open the app in the morning → see your sleep report.</a:t>
+            </a:r>
+            <a:endParaRPr lang="en-US" sz="1450" dirty="0"/>
+          </a:p>
+        </p:txBody>
+      </p:sp>
+      <p:sp>
+        <p:nvSpPr>
+          <p:cNvPr id="14" name="Shape 12"/>
+          <p:cNvSpPr/>
+          <p:nvPr/>
+        </p:nvSpPr>
+        <p:spPr>
+          <a:xfrm>
+            <a:off x="8769096" y="448056"/>
+            <a:ext cx="3081528" cy="5870448"/>
+          </a:xfrm>
+          <a:prstGeom prst="roundRect">
+            <a:avLst>
+              <a:gd name="adj" fmla="val 5341"/>
+            </a:avLst>
+          </a:prstGeom>
+          <a:solidFill>
+            <a:srgbClr val="0E1830"/>
+          </a:solidFill>
+          <a:ln w="19050">
+            <a:solidFill>
+              <a:srgbClr val="18233F"/>
+            </a:solidFill>
+            <a:prstDash val="solid"/>
+          </a:ln>
+        </p:spPr>
+      </p:sp>
+      <p:pic>
+        <p:nvPicPr>
+          <p:cNvPr id="15" name="Image 0" descr="/tmp/app_mock.png">    </p:cNvPr>
+          <p:cNvPicPr>
+            <a:picLocks noChangeAspect="1"/>
+          </p:cNvPicPr>
+          <p:nvPr/>
+        </p:nvPicPr>
+        <p:blipFill>
+          <a:blip r:embed="rId1"/>
+          <a:stretch>
+            <a:fillRect/>
+          </a:stretch>
+        </p:blipFill>
+        <p:spPr>
+          <a:xfrm>
+            <a:off x="8915400" y="594360"/>
+            <a:ext cx="2788920" cy="5577840"/>
+          </a:xfrm>
+          <a:prstGeom prst="rect">
+            <a:avLst/>
+          </a:prstGeom>
+        </p:spPr>
+      </p:pic>
+    </p:spTree>
+  </p:cSld>
+  <p:clrMapOvr>
+    <a:masterClrMapping/>
+  </p:clrMapOvr>
+</p:sld>
+</file>
+
+<file path=ppt/slides/slide4.xml><?xml version="1.0" encoding="utf-8"?>
+<p:sld xmlns:a="http://schemas.openxmlformats.org/drawingml/2006/main" xmlns:r="http://schemas.openxmlformats.org/officeDocument/2006/relationships" xmlns:p="http://schemas.openxmlformats.org/presentationml/2006/main">
+  <p:cSld name="Slide 4">
+    <p:bg>
+      <p:bgPr>
+        <a:solidFill>
           <a:srgbClr val="0E1830"/>
         </a:solidFill>
       </p:bgPr>

</xml_diff>